<commit_message>
Rewrite deck prose style
Removed em-dashes and mirrored "not X but Y" framing from slide titles,
bullets, and footers throughout. Dropped bold from in-slide body labels
and card sub-headers (kept it only on structural elements: slide titles,
eyebrow tags). Left semicolons in multi-source citation footers, since
those separate distinct citations that already contain internal commas.
Verified via geometry/overlap check (no LibreOffice available in this
session for visual render QA).
</commit_message>
<xml_diff>
--- a/deck/nigeria-tariff-policy-deck.pptx
+++ b/deck/nigeria-tariff-policy-deck.pptx
@@ -2227,7 +2227,7 @@
                 <a:ea typeface="Calibri" pitchFamily="34" charset="-122"/>
                 <a:cs typeface="Calibri" pitchFamily="34" charset="-120"/>
               </a:rPr>
-              <a:t>Commitment without a clear test — well-evidenced only for rice</a:t>
+              <a:t>Commitment without a clear test. Well-evidenced only for rice.</a:t>
             </a:r>
             <a:endParaRPr lang="en-US" sz="2500" dirty="0"/>
           </a:p>
@@ -2302,7 +2302,7 @@
               <a:buNone/>
             </a:pPr>
             <a:r>
-              <a:rPr lang="en-US" sz="1500" b="1" dirty="0">
+              <a:rPr lang="en-US" sz="1500" dirty="0">
                 <a:solidFill>
                   <a:srgbClr val="3F7A5E"/>
                 </a:solidFill>
@@ -2343,7 +2343,7 @@
                   <a:srgbClr val="3D4759"/>
                 </a:solidFill>
               </a:rPr>
-              <a:t>Rice sits on Nigeria's AfCFTA exclusion / long-timeline “sensitive” list, alongside flour, sugar, and cement — consistent with decades of food-security-driven protection.</a:t>
+              <a:t>Rice sits on Nigeria's AfCFTA exclusion or long-timeline “sensitive” list, alongside flour, sugar, and cement. That's consistent with decades of food-security-driven protection.</a:t>
             </a:r>
             <a:endParaRPr lang="en-US" sz="1300" dirty="0"/>
           </a:p>
@@ -2418,7 +2418,7 @@
               <a:buNone/>
             </a:pPr>
             <a:r>
-              <a:rPr lang="en-US" sz="1500" b="1" dirty="0">
+              <a:rPr lang="en-US" sz="1500" dirty="0">
                 <a:solidFill>
                   <a:srgbClr val="8C96A3"/>
                 </a:solidFill>
@@ -2459,7 +2459,7 @@
                   <a:srgbClr val="3D4759"/>
                 </a:solidFill>
               </a:rPr>
-              <a:t>No source — primary or secondary — states where refined petroleum or automobiles sit on Nigeria's AfCFTA schedule. A clean 3-sector AfCFTA comparison cannot be made with confidence.</a:t>
+              <a:t>No source, primary or secondary, states where refined petroleum or automobiles sit on Nigeria's AfCFTA schedule. A clean 3-sector AfCFTA comparison can't be made with confidence.</a:t>
             </a:r>
             <a:endParaRPr lang="en-US" sz="1300" dirty="0"/>
           </a:p>
@@ -2518,7 +2518,7 @@
                   <a:srgbClr val="1B2A4A"/>
                 </a:solidFill>
               </a:rPr>
-              <a:t>Nigeria gazetted its AfCFTA tariff schedule only in 2025 — six years after signing. Within the 2023-2025 window, unilateral tools (subsidy policy, import bans, forex allocation) are doing far more work shaping sector outcomes than AfCFTA commitments.</a:t>
+              <a:t>Nigeria gazetted its AfCFTA tariff schedule only in 2025, six years after signing. Within the 2023-2025 window, unilateral tools (subsidy policy, import bans, forex allocation) are doing far more work shaping sector outcomes than AfCFTA commitments.</a:t>
             </a:r>
             <a:endParaRPr lang="en-US" sz="1500" dirty="0"/>
           </a:p>
@@ -2554,7 +2554,7 @@
                   <a:srgbClr val="8C96A3"/>
                 </a:solidFill>
               </a:rPr>
-              <a:t>Sources: Boysen (2024), The World Economy; WTO Trade Policy Review — Nigeria, Nov 2024; ITRC, 16 Apr 2025 — see data/raw/afcfta/sources.md</a:t>
+              <a:t>Sources: Boysen (2024), The World Economy; WTO Trade Policy Review, Nigeria, Nov 2024; ITRC, 16 Apr 2025. See data/raw/afcfta/sources.md.</a:t>
             </a:r>
             <a:endParaRPr lang="en-US" sz="800" dirty="0"/>
           </a:p>
@@ -2772,7 +2772,7 @@
               <a:buNone/>
             </a:pPr>
             <a:r>
-              <a:rPr lang="en-US" sz="1450" b="1" dirty="0">
+              <a:rPr lang="en-US" sz="1450" dirty="0">
                 <a:solidFill>
                   <a:srgbClr val="FFFFFF"/>
                 </a:solidFill>
@@ -2813,7 +2813,7 @@
                   <a:srgbClr val="CBD3E0"/>
                 </a:solidFill>
               </a:rPr>
-              <a:t>The sector with almost no tariff is undergoing the most real structural change; the sector with the highest tariff has the weakest enforcement outcome.</a:t>
+              <a:t>The sector with almost no tariff is undergoing the most real structural change. The sector with the highest tariff has the weakest enforcement outcome.</a:t>
             </a:r>
             <a:endParaRPr lang="en-US" sz="1250" dirty="0"/>
           </a:p>
@@ -2888,7 +2888,7 @@
               <a:buNone/>
             </a:pPr>
             <a:r>
-              <a:rPr lang="en-US" sz="1450" b="1" dirty="0">
+              <a:rPr lang="en-US" sz="1450" dirty="0">
                 <a:solidFill>
                   <a:srgbClr val="FFFFFF"/>
                 </a:solidFill>
@@ -3004,12 +3004,12 @@
               <a:buNone/>
             </a:pPr>
             <a:r>
-              <a:rPr lang="en-US" sz="1450" b="1" dirty="0">
+              <a:rPr lang="en-US" sz="1450" dirty="0">
                 <a:solidFill>
                   <a:srgbClr val="FFFFFF"/>
                 </a:solidFill>
               </a:rPr>
-              <a:t>Treat AfCFTA as immature, not decisive, through 2025-2026</a:t>
+              <a:t>Treat AfCFTA as immature through 2025-2026, not decisive yet</a:t>
             </a:r>
             <a:endParaRPr lang="en-US" sz="1450" dirty="0"/>
           </a:p>
@@ -3352,7 +3352,7 @@
                   <a:srgbClr val="8C96A3"/>
                 </a:solidFill>
               </a:rPr>
-              <a:t>Every figure in this deck traces to a named, dated source. Where sources conflicted, both figures are presented — see appendix notes in the paper.</a:t>
+              <a:t>Every figure in this deck traces to a named, dated source. Where sources conflicted, both figures are presented. See appendix notes in the paper.</a:t>
             </a:r>
             <a:endParaRPr lang="en-US" sz="800" dirty="0"/>
           </a:p>
@@ -3488,7 +3488,7 @@
                 <a:ea typeface="Calibri" pitchFamily="34" charset="-122"/>
                 <a:cs typeface="Calibri" pitchFamily="34" charset="-120"/>
               </a:rPr>
-              <a:t>Tariff level does not predict import-substitution outcome — a credible domestic supply response does</a:t>
+              <a:t>Tariff level doesn't predict import-substitution outcome. A credible domestic supply response does.</a:t>
             </a:r>
             <a:endParaRPr lang="en-US" sz="2500" dirty="0"/>
           </a:p>
@@ -3669,7 +3669,7 @@
                   <a:srgbClr val="3D4759"/>
                 </a:solidFill>
               </a:rPr>
-              <a:t>Fastest substitution — driven by Dangote Refinery, not policy</a:t>
+              <a:t>Fastest substitution, driven by Dangote Refinery</a:t>
             </a:r>
             <a:endParaRPr lang="en-US" sz="1250" dirty="0"/>
           </a:p>
@@ -4031,7 +4031,7 @@
                   <a:srgbClr val="3D4759"/>
                 </a:solidFill>
               </a:rPr>
-              <a:t>Heaviest wall, most persistent leakage — top-smuggled commodity</a:t>
+              <a:t>Heaviest wall, most persistent leakage, and the top-smuggled commodity</a:t>
             </a:r>
             <a:endParaRPr lang="en-US" sz="1250" dirty="0"/>
           </a:p>
@@ -4067,7 +4067,7 @@
                   <a:srgbClr val="8C96A3"/>
                 </a:solidFill>
               </a:rPr>
-              <a:t>The variable that predicts outcomes is not the tariff line — it's whether a credible domestic supply response exists behind it.</a:t>
+              <a:t>The variable that predicts outcomes isn't the tariff line. It's whether a credible domestic supply response exists behind it.</a:t>
             </a:r>
             <a:endParaRPr lang="en-US" sz="800" dirty="0"/>
           </a:p>
@@ -4620,7 +4620,7 @@
                             <a:srgbClr val="000000"/>
                           </a:solidFill>
                         </a:rPr>
-                        <a:t>Signaling — approved-then-suspended duty, import license halts</a:t>
+                        <a:t>Signaling: an approved-then-suspended duty, import license halts</a:t>
                       </a:r>
                       <a:endParaRPr lang="en-US" sz="1250" dirty="0"/>
                     </a:p>
@@ -4681,7 +4681,7 @@
                             <a:srgbClr val="000000"/>
                           </a:solidFill>
                         </a:rPr>
-                        <a:t>Fastest import substitution, via Dangote Refinery not tariff</a:t>
+                        <a:t>Fastest import substitution, driven by Dangote Refinery</a:t>
                       </a:r>
                       <a:endParaRPr lang="en-US" sz="1250" dirty="0"/>
                     </a:p>
@@ -4927,7 +4927,7 @@
                             <a:srgbClr val="000000"/>
                           </a:solidFill>
                         </a:rPr>
-                        <a:t>Protection without competitiveness — 29.0% aggregate utilization</a:t>
+                        <a:t>Protection without competitiveness: 29.0% aggregate utilization</a:t>
                       </a:r>
                       <a:endParaRPr lang="en-US" sz="1250" dirty="0"/>
                     </a:p>
@@ -5112,7 +5112,7 @@
                             <a:srgbClr val="000000"/>
                           </a:solidFill>
                         </a:rPr>
-                        <a:t>Sustained high tariff + intermittent bans/waivers</a:t>
+                        <a:t>Sustained high tariff plus intermittent bans and waivers</a:t>
                       </a:r>
                       <a:endParaRPr lang="en-US" sz="1250" dirty="0"/>
                     </a:p>
@@ -5173,7 +5173,7 @@
                             <a:srgbClr val="000000"/>
                           </a:solidFill>
                         </a:rPr>
-                        <a:t>Heaviest wall, most persistent leakage — top-smuggled commodity</a:t>
+                        <a:t>Heaviest wall, most persistent leakage, top-smuggled commodity</a:t>
                       </a:r>
                       <a:endParaRPr lang="en-US" sz="1250" dirty="0"/>
                     </a:p>
@@ -5391,7 +5391,7 @@
                 <a:ea typeface="Calibri" pitchFamily="34" charset="-122"/>
                 <a:cs typeface="Calibri" pitchFamily="34" charset="-120"/>
               </a:rPr>
-              <a:t>Near-zero tariff, fastest substitution — Dangote Refinery is doing what policy didn't</a:t>
+              <a:t>Near-zero tariff, fastest substitution. Dangote Refinery is doing what policy didn't.</a:t>
             </a:r>
             <a:endParaRPr lang="en-US" sz="2500" dirty="0"/>
           </a:p>
@@ -5454,7 +5454,7 @@
                   <a:srgbClr val="3D4759"/>
                 </a:solidFill>
               </a:rPr>
-              <a:t>Petrol import bill fell 42% in 2025 (₦15.42tn → ₦8.96tn) as Dangote reached ~85% utilization of its 650,000 bpd refinery</a:t>
+              <a:t>Petrol import bill fell 42% in 2025 (₦15.42tn to ₦8.96tn) as Dangote reached ~85% utilization of its 650,000 bpd refinery</a:t>
             </a:r>
             <a:endParaRPr lang="en-US" sz="1300" dirty="0"/>
           </a:p>
@@ -5472,7 +5472,7 @@
                   <a:srgbClr val="3D4759"/>
                 </a:solidFill>
               </a:rPr>
-              <a:t>The only dedicated petroleum tariff of the period — a 15% duty — was approved 21 Oct 2025 and suspended 13 Nov 2025, before ever taking effect</a:t>
+              <a:t>The only dedicated petroleum tariff of the period, a 15% duty, was approved 21 Oct 2025 and suspended 13 Nov 2025, before ever taking effect</a:t>
             </a:r>
             <a:endParaRPr lang="en-US" sz="1300" dirty="0"/>
           </a:p>
@@ -5487,7 +5487,7 @@
                   <a:srgbClr val="3D4759"/>
                 </a:solidFill>
               </a:rPr>
-              <a:t>2024's naira-value spike (+105%) is substantially a currency story: the naira depreciated 40.9% that year, not a volume story</a:t>
+              <a:t>2024's naira-value spike (+105%) is mostly a currency story. The naira depreciated 40.9% that year.</a:t>
             </a:r>
             <a:endParaRPr lang="en-US" sz="1300" dirty="0"/>
           </a:p>
@@ -5962,7 +5962,7 @@
                   <a:srgbClr val="3D4759"/>
                 </a:solidFill>
               </a:rPr>
-              <a:t>reported NNPC supply shortfall to Dangote, Oct 2025-mid 2026 — and an active Dangote lawsuit disputing import-license enforcement</a:t>
+              <a:t>reported NNPC supply shortfall to Dangote, Oct 2025-mid 2026. Dangote also has an active lawsuit disputing import-license enforcement.</a:t>
             </a:r>
             <a:endParaRPr lang="en-US" sz="1250" dirty="0"/>
           </a:p>
@@ -5993,12 +5993,12 @@
               <a:buNone/>
             </a:pPr>
             <a:r>
-              <a:rPr lang="en-US" sz="1400" b="1" i="1" dirty="0">
+              <a:rPr lang="en-US" sz="1400" i="1" dirty="0">
                 <a:solidFill>
                   <a:srgbClr val="D9822B"/>
                 </a:solidFill>
               </a:rPr>
-              <a:t>Read this as “genuine structural shift, immature governance” — not a settled outcome.</a:t>
+              <a:t>Read this as a genuine structural shift with governance that's still catching up.</a:t>
             </a:r>
             <a:endParaRPr lang="en-US" sz="1400" dirty="0"/>
           </a:p>
@@ -6034,7 +6034,7 @@
                   <a:srgbClr val="8C96A3"/>
                 </a:solidFill>
               </a:rPr>
-              <a:t>Sources: Nairametrics, Punch, ICIR Nigeria, Authority News, 2025-2026 — see data/raw/petroleum/sources.md</a:t>
+              <a:t>Sources: Nairametrics, Punch, ICIR Nigeria, Authority News, 2025-2026. See data/raw/petroleum/sources.md.</a:t>
             </a:r>
             <a:endParaRPr lang="en-US" sz="800" dirty="0"/>
           </a:p>
@@ -6252,7 +6252,7 @@
                   <a:srgbClr val="8C96A3"/>
                 </a:solidFill>
               </a:rPr>
-              <a:t>Source: trade.gov Nigeria Import Tariffs; NADDC, April 2024 — aggregate utilization verified at 29.0% (93,950 / 323,650 units/year)</a:t>
+              <a:t>Source: trade.gov Nigeria Import Tariffs; NADDC, April 2024. Aggregate utilization verified at 29.0% (93,950 / 323,650 units/year).</a:t>
             </a:r>
             <a:endParaRPr lang="en-US" sz="800" dirty="0"/>
           </a:p>
@@ -6472,7 +6472,7 @@
                   <a:srgbClr val="3D4759"/>
                 </a:solidFill>
               </a:rPr>
-              <a:t>The revised NAIDP was approved by Federal Executive Council in May 2023 — an executive plan, not a statute</a:t>
+              <a:t>The revised NAIDP was approved by Federal Executive Council in May 2023. That's an executive plan, not a statute.</a:t>
             </a:r>
             <a:endParaRPr lang="en-US" sz="1450" dirty="0"/>
           </a:p>
@@ -6490,7 +6490,7 @@
                   <a:srgbClr val="3D4759"/>
                 </a:solidFill>
               </a:rPr>
-              <a:t>The original NAIDP's ten-year statutory term lapsed in 2024; a successor 2024-2034 framework still awaited legal drafting as of March 2025</a:t>
+              <a:t>The original NAIDP's ten-year statutory term lapsed in 2024. A successor 2024-2034 framework still awaited legal drafting as of March 2025.</a:t>
             </a:r>
             <a:endParaRPr lang="en-US" sz="1450" dirty="0"/>
           </a:p>
@@ -6508,7 +6508,7 @@
                   <a:srgbClr val="3D4759"/>
                 </a:solidFill>
               </a:rPr>
-              <a:t>As of October 2025, stakeholders — including NADDC's own Director-General — were still demanding passage of a “NAIDP Bill”</a:t>
+              <a:t>As of October 2025, stakeholders, including NADDC's own Director-General, were still demanding passage of a “NAIDP Bill”</a:t>
             </a:r>
             <a:endParaRPr lang="en-US" sz="1450" dirty="0"/>
           </a:p>
@@ -6617,7 +6617,7 @@
                   <a:srgbClr val="9FB0CC"/>
                 </a:solidFill>
               </a:rPr>
-              <a:t>— Joseph Osanipin, NADDC Director-General, Oct 2025</a:t>
+              <a:t>Joseph Osanipin, NADDC Director-General, Oct 2025</a:t>
             </a:r>
             <a:endParaRPr lang="en-US" sz="1050" dirty="0"/>
           </a:p>
@@ -6653,7 +6653,7 @@
                   <a:srgbClr val="8C96A3"/>
                 </a:solidFill>
               </a:rPr>
-              <a:t>Sources: The Guardian Nigeria, 27 Mar 2025; Vanguard, 10 Oct 2025 — see data/raw/automobiles/sources.md</a:t>
+              <a:t>Sources: The Guardian Nigeria, 27 Mar 2025; Vanguard, 10 Oct 2025. See data/raw/automobiles/sources.md.</a:t>
             </a:r>
             <a:endParaRPr lang="en-US" sz="800" dirty="0"/>
           </a:p>
@@ -6852,7 +6852,7 @@
                   <a:srgbClr val="3D4759"/>
                 </a:solidFill>
               </a:rPr>
-              <a:t>70% combined duty + levy — among the heaviest in Nigeria's tariff schedule, roughly stable since 2013</a:t>
+              <a:t>70% combined duty and levy: among the heaviest in Nigeria's tariff schedule, roughly stable since 2013</a:t>
             </a:r>
             <a:endParaRPr lang="en-US" sz="1300" dirty="0"/>
           </a:p>
@@ -6885,7 +6885,7 @@
                   <a:srgbClr val="3D4759"/>
                 </a:solidFill>
               </a:rPr>
-              <a:t>The 2019 land-border closure remains only partially reversed — rice stayed formally banned even after Dec 2020 reopening</a:t>
+              <a:t>The 2019 land-border closure remains only partially reversed. Rice stayed formally banned even after the Dec 2020 reopening.</a:t>
             </a:r>
             <a:endParaRPr lang="en-US" sz="1300" dirty="0"/>
           </a:p>
@@ -6921,7 +6921,7 @@
                   <a:srgbClr val="8C96A3"/>
                 </a:solidFill>
               </a:rPr>
-              <a:t>Sources: USDA FAS Grain and Feed Annual, 13 Mar 2024; PRNigeria, 24 Apr 2025 — see data/raw/rice/sources.md</a:t>
+              <a:t>Sources: USDA FAS Grain and Feed Annual, 13 Mar 2024; PRNigeria, 24 Apr 2025. See data/raw/rice/sources.md.</a:t>
             </a:r>
             <a:endParaRPr lang="en-US" sz="800" dirty="0"/>
           </a:p>
@@ -7057,7 +7057,7 @@
                 <a:ea typeface="Calibri" pitchFamily="34" charset="-122"/>
                 <a:cs typeface="Calibri" pitchFamily="34" charset="-120"/>
               </a:rPr>
-              <a:t>Tariff level is inversely related to substitution outcome across all 3 sectors</a:t>
+              <a:t>Tariff level runs inversely to substitution outcome across all 3 sectors</a:t>
             </a:r>
             <a:endParaRPr lang="en-US" sz="2500" dirty="0"/>
           </a:p>
@@ -7116,7 +7116,7 @@
                   <a:srgbClr val="8C96A3"/>
                 </a:solidFill>
               </a:rPr>
-              <a:t>Source: see data/raw/{petroleum,automobiles,rice}/sources.md for underlying citations</a:t>
+              <a:t>Source: see data/raw/{petroleum,automobiles,rice}/sources.md for underlying citations.</a:t>
             </a:r>
             <a:endParaRPr lang="en-US" sz="800" dirty="0"/>
           </a:p>

</xml_diff>

<commit_message>
Add cross-sector framework: tariff level vs. supply-response credibility
New 2x2-style exhibit visualizing the paper's central finding directly --
plotting each sector on tariff level (x) and domestic supply-response
credibility (y) separates the three cases cleanly along the vertical axis,
not the horizontal one. Credibility positioning is explicitly qualitative,
grounded in the cited evidence, not a fabricated precision score.

Embedded across all four deliverables: a new Figure 8 in the academic
paper, a new exhibit in the policy paper's synthesis section, a new slide
in the deck (renumbered 10-13), and a new interactive Recharts scatter
section in the dashboard with hover tooltips surfacing the grounding
rationale per sector.
</commit_message>
<xml_diff>
--- a/deck/nigeria-tariff-policy-deck.pptx
+++ b/deck/nigeria-tariff-policy-deck.pptx
@@ -17,9 +17,10 @@
     <p:sldId id="265" r:id="rId11"/>
     <p:sldId id="266" r:id="rId12"/>
     <p:sldId id="267" r:id="rId13"/>
+    <p:sldId id="268" r:id="rId14"/>
   </p:sldIdLst>
   <p:notesMasterIdLst>
-    <p:notesMasterId r:id="rId14"/>
+    <p:notesMasterId r:id="rId15"/>
   </p:notesMasterIdLst>
   <p:sldSz cx="12192000" cy="6858000"/>
   <p:notesSz cx="6858000" cy="12192000"/>
@@ -801,6 +802,94 @@
             <a:fld id="{F7021451-1387-4CA6-816F-3879F97B5CBC}" type="slidenum">
               <a:rPr lang="en-US"/>
               <a:t>12</a:t>
+            </a:fld>
+            <a:endParaRPr lang="en-US"/>
+          </a:p>
+        </p:txBody>
+      </p:sp>
+    </p:spTree>
+    <p:extLst>
+      <p:ext uri="{BB962C8B-B14F-4D97-AF65-F5344CB8AC3E}">
+        <p14:creationId xmlns:p14="http://schemas.microsoft.com/office/powerpoint/2010/main" val="1024086991"/>
+      </p:ext>
+    </p:extLst>
+  </p:cSld>
+  <p:clrMapOvr>
+    <a:masterClrMapping/>
+  </p:clrMapOvr>
+</p:notes>
+</file>
+
+<file path=ppt/notesSlides/notesSlide13.xml><?xml version="1.0" encoding="utf-8"?>
+<p:notes xmlns:a="http://schemas.openxmlformats.org/drawingml/2006/main" xmlns:r="http://schemas.openxmlformats.org/officeDocument/2006/relationships" xmlns:p="http://schemas.openxmlformats.org/presentationml/2006/main">
+  <p:cSld>
+    <p:spTree>
+      <p:nvGrpSpPr>
+        <p:cNvPr id="1" name=""/>
+        <p:cNvGrpSpPr/>
+        <p:nvPr/>
+      </p:nvGrpSpPr>
+      <p:grpSpPr>
+        <a:xfrm>
+          <a:off x="0" y="0"/>
+          <a:ext cx="0" cy="0"/>
+          <a:chOff x="0" y="0"/>
+          <a:chExt cx="0" cy="0"/>
+        </a:xfrm>
+      </p:grpSpPr>
+      <p:sp>
+        <p:nvSpPr>
+          <p:cNvPr id="2" name="Slide Image Placeholder 1"/>
+          <p:cNvSpPr>
+            <a:spLocks noGrp="1" noRot="1" noChangeAspect="1"/>
+          </p:cNvSpPr>
+          <p:nvPr>
+            <p:ph type="sldImg"/>
+          </p:nvPr>
+        </p:nvSpPr>
+        <p:spPr/>
+      </p:sp>
+      <p:sp>
+        <p:nvSpPr>
+          <p:cNvPr id="3" name="Notes Placeholder 2"/>
+          <p:cNvSpPr>
+            <a:spLocks noGrp="1"/>
+          </p:cNvSpPr>
+          <p:nvPr>
+            <p:ph type="body" idx="1"/>
+          </p:nvPr>
+        </p:nvSpPr>
+        <p:spPr/>
+        <p:txBody>
+          <a:bodyPr/>
+          <a:lstStyle/>
+          <a:p>
+            <a:r>
+              <a:rPr lang="en-US" dirty="0"/>
+              <a:t/>
+            </a:r>
+            <a:endParaRPr lang="en-US" dirty="0"/>
+          </a:p>
+        </p:txBody>
+      </p:sp>
+      <p:sp>
+        <p:nvSpPr>
+          <p:cNvPr id="4" name="Slide Number Placeholder 3"/>
+          <p:cNvSpPr>
+            <a:spLocks noGrp="1"/>
+          </p:cNvSpPr>
+          <p:nvPr>
+            <p:ph type="sldNum" sz="quarter" idx="10"/>
+          </p:nvPr>
+        </p:nvSpPr>
+        <p:spPr/>
+        <p:txBody>
+          <a:bodyPr/>
+          <a:lstStyle/>
+          <a:p>
+            <a:fld id="{F7021451-1387-4CA6-816F-3879F97B5CBC}" type="slidenum">
+              <a:rPr lang="en-US"/>
+              <a:t>13</a:t>
             </a:fld>
             <a:endParaRPr lang="en-US"/>
           </a:p>
@@ -2185,10 +2274,10 @@
             <a:r>
               <a:rPr lang="en-US" sz="1200" b="1" spc="150" kern="0" dirty="0">
                 <a:solidFill>
-                  <a:srgbClr val="3F7A5E"/>
-                </a:solidFill>
-              </a:rPr>
-              <a:t>THE AFCFTA QUESTION</a:t>
+                  <a:srgbClr val="D9822B"/>
+                </a:solidFill>
+              </a:rPr>
+              <a:t>THE FRAMEWORK</a:t>
             </a:r>
             <a:endParaRPr lang="en-US" sz="1200" dirty="0"/>
           </a:p>
@@ -2227,35 +2316,15 @@
                 <a:ea typeface="Calibri" pitchFamily="34" charset="-122"/>
                 <a:cs typeface="Calibri" pitchFamily="34" charset="-120"/>
               </a:rPr>
-              <a:t>Commitment without a clear test. Well-evidenced only for rice.</a:t>
+              <a:t>The vertical axis predicts substitution. The horizontal one doesn't.</a:t>
             </a:r>
             <a:endParaRPr lang="en-US" sz="2500" dirty="0"/>
           </a:p>
         </p:txBody>
-      </p:sp>
-      <p:sp>
-        <p:nvSpPr>
-          <p:cNvPr id="4" name="Shape 2"/>
-          <p:cNvSpPr/>
-          <p:nvPr/>
-        </p:nvSpPr>
-        <p:spPr>
-          <a:xfrm>
-            <a:off x="548640" y="2011680"/>
-            <a:ext cx="914400" cy="914400"/>
-          </a:xfrm>
-          <a:prstGeom prst="ellipse">
-            <a:avLst/>
-          </a:prstGeom>
-          <a:solidFill>
-            <a:srgbClr val="3F7A5E"/>
-          </a:solidFill>
-          <a:ln/>
-        </p:spPr>
       </p:sp>
       <p:pic>
         <p:nvPicPr>
-          <p:cNvPr id="5" name="Image 0" descr="preencoded.png">    </p:cNvPr>
+          <p:cNvPr id="4" name="Image 0" descr="C:\Users\HP\nigeria-tariff-research\outputs\charts\framework_matrix.png">    </p:cNvPr>
           <p:cNvPicPr>
             <a:picLocks noChangeAspect="1"/>
           </p:cNvPicPr>
@@ -2263,14 +2332,13 @@
         </p:nvPicPr>
         <p:blipFill>
           <a:blip r:embed="rId1"/>
-          <a:stretch>
-            <a:fillRect/>
-          </a:stretch>
+          <a:srcRect l="0" r="0" t="0" b="0"/>
+          <a:stretch/>
         </p:blipFill>
         <p:spPr>
           <a:xfrm>
-            <a:off x="676656" y="2139696"/>
-            <a:ext cx="658368" cy="658368"/>
+            <a:off x="2148840" y="1691640"/>
+            <a:ext cx="7863840" cy="4663440"/>
           </a:xfrm>
           <a:prstGeom prst="rect">
             <a:avLst/>
@@ -2279,254 +2347,7 @@
       </p:pic>
       <p:sp>
         <p:nvSpPr>
-          <p:cNvPr id="6" name="Text 3"/>
-          <p:cNvSpPr/>
-          <p:nvPr/>
-        </p:nvSpPr>
-        <p:spPr>
-          <a:xfrm>
-            <a:off x="1828800" y="1965960"/>
-            <a:ext cx="4572000" cy="365760"/>
-          </a:xfrm>
-          <a:prstGeom prst="rect">
-            <a:avLst/>
-          </a:prstGeom>
-          <a:noFill/>
-          <a:ln/>
-        </p:spPr>
-        <p:txBody>
-          <a:bodyPr wrap="square" rtlCol="0" anchor="ctr"/>
-          <a:lstStyle/>
-          <a:p>
-            <a:pPr indent="0" marL="0">
-              <a:buNone/>
-            </a:pPr>
-            <a:r>
-              <a:rPr lang="en-US" sz="1500" dirty="0">
-                <a:solidFill>
-                  <a:srgbClr val="3F7A5E"/>
-                </a:solidFill>
-              </a:rPr>
-              <a:t>Clear finding</a:t>
-            </a:r>
-            <a:endParaRPr lang="en-US" sz="1500" dirty="0"/>
-          </a:p>
-        </p:txBody>
-      </p:sp>
-      <p:sp>
-        <p:nvSpPr>
-          <p:cNvPr id="7" name="Text 4"/>
-          <p:cNvSpPr/>
-          <p:nvPr/>
-        </p:nvSpPr>
-        <p:spPr>
-          <a:xfrm>
-            <a:off x="1828800" y="2377440"/>
-            <a:ext cx="4663440" cy="1371600"/>
-          </a:xfrm>
-          <a:prstGeom prst="rect">
-            <a:avLst/>
-          </a:prstGeom>
-          <a:noFill/>
-          <a:ln/>
-        </p:spPr>
-        <p:txBody>
-          <a:bodyPr wrap="square" rtlCol="0" anchor="t"/>
-          <a:lstStyle/>
-          <a:p>
-            <a:pPr indent="0" marL="0">
-              <a:buNone/>
-            </a:pPr>
-            <a:r>
-              <a:rPr lang="en-US" sz="1300" dirty="0">
-                <a:solidFill>
-                  <a:srgbClr val="3D4759"/>
-                </a:solidFill>
-              </a:rPr>
-              <a:t>Rice sits on Nigeria's AfCFTA exclusion or long-timeline “sensitive” list, alongside flour, sugar, and cement. That's consistent with decades of food-security-driven protection.</a:t>
-            </a:r>
-            <a:endParaRPr lang="en-US" sz="1300" dirty="0"/>
-          </a:p>
-        </p:txBody>
-      </p:sp>
-      <p:sp>
-        <p:nvSpPr>
-          <p:cNvPr id="8" name="Shape 5"/>
-          <p:cNvSpPr/>
-          <p:nvPr/>
-        </p:nvSpPr>
-        <p:spPr>
-          <a:xfrm>
-            <a:off x="6492240" y="2011680"/>
-            <a:ext cx="914400" cy="914400"/>
-          </a:xfrm>
-          <a:prstGeom prst="ellipse">
-            <a:avLst/>
-          </a:prstGeom>
-          <a:solidFill>
-            <a:srgbClr val="8C96A3"/>
-          </a:solidFill>
-          <a:ln/>
-        </p:spPr>
-      </p:sp>
-      <p:pic>
-        <p:nvPicPr>
-          <p:cNvPr id="9" name="Image 1" descr="preencoded.png">    </p:cNvPr>
-          <p:cNvPicPr>
-            <a:picLocks noChangeAspect="1"/>
-          </p:cNvPicPr>
-          <p:nvPr/>
-        </p:nvPicPr>
-        <p:blipFill>
-          <a:blip r:embed="rId2"/>
-          <a:stretch>
-            <a:fillRect/>
-          </a:stretch>
-        </p:blipFill>
-        <p:spPr>
-          <a:xfrm>
-            <a:off x="6620256" y="2139696"/>
-            <a:ext cx="658368" cy="658368"/>
-          </a:xfrm>
-          <a:prstGeom prst="rect">
-            <a:avLst/>
-          </a:prstGeom>
-        </p:spPr>
-      </p:pic>
-      <p:sp>
-        <p:nvSpPr>
-          <p:cNvPr id="10" name="Text 6"/>
-          <p:cNvSpPr/>
-          <p:nvPr/>
-        </p:nvSpPr>
-        <p:spPr>
-          <a:xfrm>
-            <a:off x="7772400" y="1965960"/>
-            <a:ext cx="3931920" cy="365760"/>
-          </a:xfrm>
-          <a:prstGeom prst="rect">
-            <a:avLst/>
-          </a:prstGeom>
-          <a:noFill/>
-          <a:ln/>
-        </p:spPr>
-        <p:txBody>
-          <a:bodyPr wrap="square" rtlCol="0" anchor="ctr"/>
-          <a:lstStyle/>
-          <a:p>
-            <a:pPr indent="0" marL="0">
-              <a:buNone/>
-            </a:pPr>
-            <a:r>
-              <a:rPr lang="en-US" sz="1500" dirty="0">
-                <a:solidFill>
-                  <a:srgbClr val="8C96A3"/>
-                </a:solidFill>
-              </a:rPr>
-              <a:t>Important non-finding</a:t>
-            </a:r>
-            <a:endParaRPr lang="en-US" sz="1500" dirty="0"/>
-          </a:p>
-        </p:txBody>
-      </p:sp>
-      <p:sp>
-        <p:nvSpPr>
-          <p:cNvPr id="11" name="Text 7"/>
-          <p:cNvSpPr/>
-          <p:nvPr/>
-        </p:nvSpPr>
-        <p:spPr>
-          <a:xfrm>
-            <a:off x="7772400" y="2377440"/>
-            <a:ext cx="3931920" cy="1737360"/>
-          </a:xfrm>
-          <a:prstGeom prst="rect">
-            <a:avLst/>
-          </a:prstGeom>
-          <a:noFill/>
-          <a:ln/>
-        </p:spPr>
-        <p:txBody>
-          <a:bodyPr wrap="square" rtlCol="0" anchor="t"/>
-          <a:lstStyle/>
-          <a:p>
-            <a:pPr indent="0" marL="0">
-              <a:buNone/>
-            </a:pPr>
-            <a:r>
-              <a:rPr lang="en-US" sz="1300" dirty="0">
-                <a:solidFill>
-                  <a:srgbClr val="3D4759"/>
-                </a:solidFill>
-              </a:rPr>
-              <a:t>No source, primary or secondary, states where refined petroleum or automobiles sit on Nigeria's AfCFTA schedule. A clean 3-sector AfCFTA comparison can't be made with confidence.</a:t>
-            </a:r>
-            <a:endParaRPr lang="en-US" sz="1300" dirty="0"/>
-          </a:p>
-        </p:txBody>
-      </p:sp>
-      <p:sp>
-        <p:nvSpPr>
-          <p:cNvPr id="12" name="Shape 8"/>
-          <p:cNvSpPr/>
-          <p:nvPr/>
-        </p:nvSpPr>
-        <p:spPr>
-          <a:xfrm>
-            <a:off x="457200" y="3977640"/>
-            <a:ext cx="11247120" cy="0"/>
-          </a:xfrm>
-          <a:prstGeom prst="line">
-            <a:avLst/>
-          </a:prstGeom>
-          <a:noFill/>
-          <a:ln w="12700">
-            <a:solidFill>
-              <a:srgbClr val="E2E5EA"/>
-            </a:solidFill>
-            <a:prstDash val="solid"/>
-          </a:ln>
-        </p:spPr>
-      </p:sp>
-      <p:sp>
-        <p:nvSpPr>
-          <p:cNvPr id="13" name="Text 9"/>
-          <p:cNvSpPr/>
-          <p:nvPr/>
-        </p:nvSpPr>
-        <p:spPr>
-          <a:xfrm>
-            <a:off x="457200" y="4297680"/>
-            <a:ext cx="11247120" cy="1188720"/>
-          </a:xfrm>
-          <a:prstGeom prst="rect">
-            <a:avLst/>
-          </a:prstGeom>
-          <a:noFill/>
-          <a:ln/>
-        </p:spPr>
-        <p:txBody>
-          <a:bodyPr wrap="square" rtlCol="0" anchor="t"/>
-          <a:lstStyle/>
-          <a:p>
-            <a:pPr indent="0" marL="0">
-              <a:buNone/>
-            </a:pPr>
-            <a:r>
-              <a:rPr lang="en-US" sz="1500" i="1" dirty="0">
-                <a:solidFill>
-                  <a:srgbClr val="1B2A4A"/>
-                </a:solidFill>
-              </a:rPr>
-              <a:t>Nigeria gazetted its AfCFTA tariff schedule only in 2025, six years after signing. Within the 2023-2025 window, unilateral tools (subsidy policy, import bans, forex allocation) are doing far more work shaping sector outcomes than AfCFTA commitments.</a:t>
-            </a:r>
-            <a:endParaRPr lang="en-US" sz="1500" dirty="0"/>
-          </a:p>
-        </p:txBody>
-      </p:sp>
-      <p:sp>
-        <p:nvSpPr>
-          <p:cNvPr id="14" name="Text 10"/>
+          <p:cNvPr id="5" name="Text 2"/>
           <p:cNvSpPr/>
           <p:nvPr/>
         </p:nvSpPr>
@@ -2554,7 +2375,7 @@
                   <a:srgbClr val="8C96A3"/>
                 </a:solidFill>
               </a:rPr>
-              <a:t>Sources: Boysen (2024), The World Economy; WTO Trade Policy Review, Nigeria, Nov 2024; ITRC, 16 Apr 2025. See data/raw/afcfta/sources.md.</a:t>
+              <a:t>Credibility positioning is qualitative, grounded in the evidence in Sections 4-9. Automobiles plotted at the midpoint of its 35-40% range.</a:t>
             </a:r>
             <a:endParaRPr lang="en-US" sz="800" dirty="0"/>
           </a:p>
@@ -2562,7 +2383,7 @@
       </p:sp>
       <p:sp>
         <p:nvSpPr>
-          <p:cNvPr id="15" name="Text 11"/>
+          <p:cNvPr id="6" name="Text 3"/>
           <p:cNvSpPr/>
           <p:nvPr/>
         </p:nvSpPr>
@@ -2607,6 +2428,469 @@
 <file path=ppt/slides/slide11.xml><?xml version="1.0" encoding="utf-8"?>
 <p:sld xmlns:a="http://schemas.openxmlformats.org/drawingml/2006/main" xmlns:r="http://schemas.openxmlformats.org/officeDocument/2006/relationships" xmlns:p="http://schemas.openxmlformats.org/presentationml/2006/main">
   <p:cSld name="Slide 11">
+    <p:spTree>
+      <p:nvGrpSpPr>
+        <p:cNvPr id="1" name=""/>
+        <p:cNvGrpSpPr/>
+        <p:nvPr/>
+      </p:nvGrpSpPr>
+      <p:grpSpPr>
+        <a:xfrm>
+          <a:off x="0" y="0"/>
+          <a:ext cx="0" cy="0"/>
+          <a:chOff x="0" y="0"/>
+          <a:chExt cx="0" cy="0"/>
+        </a:xfrm>
+      </p:grpSpPr>
+      <p:sp>
+        <p:nvSpPr>
+          <p:cNvPr id="2" name="Text 0"/>
+          <p:cNvSpPr/>
+          <p:nvPr/>
+        </p:nvSpPr>
+        <p:spPr>
+          <a:xfrm>
+            <a:off x="457200" y="320040"/>
+            <a:ext cx="7315200" cy="320040"/>
+          </a:xfrm>
+          <a:prstGeom prst="rect">
+            <a:avLst/>
+          </a:prstGeom>
+          <a:noFill/>
+          <a:ln/>
+        </p:spPr>
+        <p:txBody>
+          <a:bodyPr wrap="square" rtlCol="0" anchor="ctr"/>
+          <a:lstStyle/>
+          <a:p>
+            <a:pPr indent="0" marL="0">
+              <a:buNone/>
+            </a:pPr>
+            <a:r>
+              <a:rPr lang="en-US" sz="1200" b="1" spc="150" kern="0" dirty="0">
+                <a:solidFill>
+                  <a:srgbClr val="3F7A5E"/>
+                </a:solidFill>
+              </a:rPr>
+              <a:t>THE AFCFTA QUESTION</a:t>
+            </a:r>
+            <a:endParaRPr lang="en-US" sz="1200" dirty="0"/>
+          </a:p>
+        </p:txBody>
+      </p:sp>
+      <p:sp>
+        <p:nvSpPr>
+          <p:cNvPr id="3" name="Text 1"/>
+          <p:cNvSpPr/>
+          <p:nvPr/>
+        </p:nvSpPr>
+        <p:spPr>
+          <a:xfrm>
+            <a:off x="457200" y="694944"/>
+            <a:ext cx="11247120" cy="822960"/>
+          </a:xfrm>
+          <a:prstGeom prst="rect">
+            <a:avLst/>
+          </a:prstGeom>
+          <a:noFill/>
+          <a:ln/>
+        </p:spPr>
+        <p:txBody>
+          <a:bodyPr wrap="square" rtlCol="0" anchor="ctr"/>
+          <a:lstStyle/>
+          <a:p>
+            <a:pPr indent="0" marL="0">
+              <a:buNone/>
+            </a:pPr>
+            <a:r>
+              <a:rPr lang="en-US" sz="2500" b="1" dirty="0">
+                <a:solidFill>
+                  <a:srgbClr val="1B2A4A"/>
+                </a:solidFill>
+                <a:latin typeface="Calibri" pitchFamily="34" charset="0"/>
+                <a:ea typeface="Calibri" pitchFamily="34" charset="-122"/>
+                <a:cs typeface="Calibri" pitchFamily="34" charset="-120"/>
+              </a:rPr>
+              <a:t>Commitment without a clear test. Well-evidenced only for rice.</a:t>
+            </a:r>
+            <a:endParaRPr lang="en-US" sz="2500" dirty="0"/>
+          </a:p>
+        </p:txBody>
+      </p:sp>
+      <p:sp>
+        <p:nvSpPr>
+          <p:cNvPr id="4" name="Shape 2"/>
+          <p:cNvSpPr/>
+          <p:nvPr/>
+        </p:nvSpPr>
+        <p:spPr>
+          <a:xfrm>
+            <a:off x="548640" y="2011680"/>
+            <a:ext cx="914400" cy="914400"/>
+          </a:xfrm>
+          <a:prstGeom prst="ellipse">
+            <a:avLst/>
+          </a:prstGeom>
+          <a:solidFill>
+            <a:srgbClr val="3F7A5E"/>
+          </a:solidFill>
+          <a:ln/>
+        </p:spPr>
+      </p:sp>
+      <p:pic>
+        <p:nvPicPr>
+          <p:cNvPr id="5" name="Image 0" descr="preencoded.png">    </p:cNvPr>
+          <p:cNvPicPr>
+            <a:picLocks noChangeAspect="1"/>
+          </p:cNvPicPr>
+          <p:nvPr/>
+        </p:nvPicPr>
+        <p:blipFill>
+          <a:blip r:embed="rId1"/>
+          <a:stretch>
+            <a:fillRect/>
+          </a:stretch>
+        </p:blipFill>
+        <p:spPr>
+          <a:xfrm>
+            <a:off x="676656" y="2139696"/>
+            <a:ext cx="658368" cy="658368"/>
+          </a:xfrm>
+          <a:prstGeom prst="rect">
+            <a:avLst/>
+          </a:prstGeom>
+        </p:spPr>
+      </p:pic>
+      <p:sp>
+        <p:nvSpPr>
+          <p:cNvPr id="6" name="Text 3"/>
+          <p:cNvSpPr/>
+          <p:nvPr/>
+        </p:nvSpPr>
+        <p:spPr>
+          <a:xfrm>
+            <a:off x="1828800" y="1965960"/>
+            <a:ext cx="4572000" cy="365760"/>
+          </a:xfrm>
+          <a:prstGeom prst="rect">
+            <a:avLst/>
+          </a:prstGeom>
+          <a:noFill/>
+          <a:ln/>
+        </p:spPr>
+        <p:txBody>
+          <a:bodyPr wrap="square" rtlCol="0" anchor="ctr"/>
+          <a:lstStyle/>
+          <a:p>
+            <a:pPr indent="0" marL="0">
+              <a:buNone/>
+            </a:pPr>
+            <a:r>
+              <a:rPr lang="en-US" sz="1500" dirty="0">
+                <a:solidFill>
+                  <a:srgbClr val="3F7A5E"/>
+                </a:solidFill>
+              </a:rPr>
+              <a:t>Clear finding</a:t>
+            </a:r>
+            <a:endParaRPr lang="en-US" sz="1500" dirty="0"/>
+          </a:p>
+        </p:txBody>
+      </p:sp>
+      <p:sp>
+        <p:nvSpPr>
+          <p:cNvPr id="7" name="Text 4"/>
+          <p:cNvSpPr/>
+          <p:nvPr/>
+        </p:nvSpPr>
+        <p:spPr>
+          <a:xfrm>
+            <a:off x="1828800" y="2377440"/>
+            <a:ext cx="4663440" cy="1371600"/>
+          </a:xfrm>
+          <a:prstGeom prst="rect">
+            <a:avLst/>
+          </a:prstGeom>
+          <a:noFill/>
+          <a:ln/>
+        </p:spPr>
+        <p:txBody>
+          <a:bodyPr wrap="square" rtlCol="0" anchor="t"/>
+          <a:lstStyle/>
+          <a:p>
+            <a:pPr indent="0" marL="0">
+              <a:buNone/>
+            </a:pPr>
+            <a:r>
+              <a:rPr lang="en-US" sz="1300" dirty="0">
+                <a:solidFill>
+                  <a:srgbClr val="3D4759"/>
+                </a:solidFill>
+              </a:rPr>
+              <a:t>Rice sits on Nigeria's AfCFTA exclusion or long-timeline “sensitive” list, alongside flour, sugar, and cement. That's consistent with decades of food-security-driven protection.</a:t>
+            </a:r>
+            <a:endParaRPr lang="en-US" sz="1300" dirty="0"/>
+          </a:p>
+        </p:txBody>
+      </p:sp>
+      <p:sp>
+        <p:nvSpPr>
+          <p:cNvPr id="8" name="Shape 5"/>
+          <p:cNvSpPr/>
+          <p:nvPr/>
+        </p:nvSpPr>
+        <p:spPr>
+          <a:xfrm>
+            <a:off x="6492240" y="2011680"/>
+            <a:ext cx="914400" cy="914400"/>
+          </a:xfrm>
+          <a:prstGeom prst="ellipse">
+            <a:avLst/>
+          </a:prstGeom>
+          <a:solidFill>
+            <a:srgbClr val="8C96A3"/>
+          </a:solidFill>
+          <a:ln/>
+        </p:spPr>
+      </p:sp>
+      <p:pic>
+        <p:nvPicPr>
+          <p:cNvPr id="9" name="Image 1" descr="preencoded.png">    </p:cNvPr>
+          <p:cNvPicPr>
+            <a:picLocks noChangeAspect="1"/>
+          </p:cNvPicPr>
+          <p:nvPr/>
+        </p:nvPicPr>
+        <p:blipFill>
+          <a:blip r:embed="rId2"/>
+          <a:stretch>
+            <a:fillRect/>
+          </a:stretch>
+        </p:blipFill>
+        <p:spPr>
+          <a:xfrm>
+            <a:off x="6620256" y="2139696"/>
+            <a:ext cx="658368" cy="658368"/>
+          </a:xfrm>
+          <a:prstGeom prst="rect">
+            <a:avLst/>
+          </a:prstGeom>
+        </p:spPr>
+      </p:pic>
+      <p:sp>
+        <p:nvSpPr>
+          <p:cNvPr id="10" name="Text 6"/>
+          <p:cNvSpPr/>
+          <p:nvPr/>
+        </p:nvSpPr>
+        <p:spPr>
+          <a:xfrm>
+            <a:off x="7772400" y="1965960"/>
+            <a:ext cx="3931920" cy="365760"/>
+          </a:xfrm>
+          <a:prstGeom prst="rect">
+            <a:avLst/>
+          </a:prstGeom>
+          <a:noFill/>
+          <a:ln/>
+        </p:spPr>
+        <p:txBody>
+          <a:bodyPr wrap="square" rtlCol="0" anchor="ctr"/>
+          <a:lstStyle/>
+          <a:p>
+            <a:pPr indent="0" marL="0">
+              <a:buNone/>
+            </a:pPr>
+            <a:r>
+              <a:rPr lang="en-US" sz="1500" dirty="0">
+                <a:solidFill>
+                  <a:srgbClr val="8C96A3"/>
+                </a:solidFill>
+              </a:rPr>
+              <a:t>Important non-finding</a:t>
+            </a:r>
+            <a:endParaRPr lang="en-US" sz="1500" dirty="0"/>
+          </a:p>
+        </p:txBody>
+      </p:sp>
+      <p:sp>
+        <p:nvSpPr>
+          <p:cNvPr id="11" name="Text 7"/>
+          <p:cNvSpPr/>
+          <p:nvPr/>
+        </p:nvSpPr>
+        <p:spPr>
+          <a:xfrm>
+            <a:off x="7772400" y="2377440"/>
+            <a:ext cx="3931920" cy="1737360"/>
+          </a:xfrm>
+          <a:prstGeom prst="rect">
+            <a:avLst/>
+          </a:prstGeom>
+          <a:noFill/>
+          <a:ln/>
+        </p:spPr>
+        <p:txBody>
+          <a:bodyPr wrap="square" rtlCol="0" anchor="t"/>
+          <a:lstStyle/>
+          <a:p>
+            <a:pPr indent="0" marL="0">
+              <a:buNone/>
+            </a:pPr>
+            <a:r>
+              <a:rPr lang="en-US" sz="1300" dirty="0">
+                <a:solidFill>
+                  <a:srgbClr val="3D4759"/>
+                </a:solidFill>
+              </a:rPr>
+              <a:t>No source, primary or secondary, states where refined petroleum or automobiles sit on Nigeria's AfCFTA schedule. A clean 3-sector AfCFTA comparison can't be made with confidence.</a:t>
+            </a:r>
+            <a:endParaRPr lang="en-US" sz="1300" dirty="0"/>
+          </a:p>
+        </p:txBody>
+      </p:sp>
+      <p:sp>
+        <p:nvSpPr>
+          <p:cNvPr id="12" name="Shape 8"/>
+          <p:cNvSpPr/>
+          <p:nvPr/>
+        </p:nvSpPr>
+        <p:spPr>
+          <a:xfrm>
+            <a:off x="457200" y="3977640"/>
+            <a:ext cx="11247120" cy="0"/>
+          </a:xfrm>
+          <a:prstGeom prst="line">
+            <a:avLst/>
+          </a:prstGeom>
+          <a:noFill/>
+          <a:ln w="12700">
+            <a:solidFill>
+              <a:srgbClr val="E2E5EA"/>
+            </a:solidFill>
+            <a:prstDash val="solid"/>
+          </a:ln>
+        </p:spPr>
+      </p:sp>
+      <p:sp>
+        <p:nvSpPr>
+          <p:cNvPr id="13" name="Text 9"/>
+          <p:cNvSpPr/>
+          <p:nvPr/>
+        </p:nvSpPr>
+        <p:spPr>
+          <a:xfrm>
+            <a:off x="457200" y="4297680"/>
+            <a:ext cx="11247120" cy="1188720"/>
+          </a:xfrm>
+          <a:prstGeom prst="rect">
+            <a:avLst/>
+          </a:prstGeom>
+          <a:noFill/>
+          <a:ln/>
+        </p:spPr>
+        <p:txBody>
+          <a:bodyPr wrap="square" rtlCol="0" anchor="t"/>
+          <a:lstStyle/>
+          <a:p>
+            <a:pPr indent="0" marL="0">
+              <a:buNone/>
+            </a:pPr>
+            <a:r>
+              <a:rPr lang="en-US" sz="1500" i="1" dirty="0">
+                <a:solidFill>
+                  <a:srgbClr val="1B2A4A"/>
+                </a:solidFill>
+              </a:rPr>
+              <a:t>Nigeria gazetted its AfCFTA tariff schedule only in 2025, six years after signing. Within the 2023-2025 window, unilateral tools (subsidy policy, import bans, forex allocation) are doing far more work shaping sector outcomes than AfCFTA commitments.</a:t>
+            </a:r>
+            <a:endParaRPr lang="en-US" sz="1500" dirty="0"/>
+          </a:p>
+        </p:txBody>
+      </p:sp>
+      <p:sp>
+        <p:nvSpPr>
+          <p:cNvPr id="14" name="Text 10"/>
+          <p:cNvSpPr/>
+          <p:nvPr/>
+        </p:nvSpPr>
+        <p:spPr>
+          <a:xfrm>
+            <a:off x="457200" y="6446520"/>
+            <a:ext cx="10515600" cy="274320"/>
+          </a:xfrm>
+          <a:prstGeom prst="rect">
+            <a:avLst/>
+          </a:prstGeom>
+          <a:noFill/>
+          <a:ln/>
+        </p:spPr>
+        <p:txBody>
+          <a:bodyPr wrap="square" rtlCol="0" anchor="ctr"/>
+          <a:lstStyle/>
+          <a:p>
+            <a:pPr indent="0" marL="0">
+              <a:buNone/>
+            </a:pPr>
+            <a:r>
+              <a:rPr lang="en-US" sz="800" i="1" dirty="0">
+                <a:solidFill>
+                  <a:srgbClr val="8C96A3"/>
+                </a:solidFill>
+              </a:rPr>
+              <a:t>Sources: Boysen (2024), The World Economy; WTO Trade Policy Review, Nigeria, Nov 2024; ITRC, 16 Apr 2025. See data/raw/afcfta/sources.md.</a:t>
+            </a:r>
+            <a:endParaRPr lang="en-US" sz="800" dirty="0"/>
+          </a:p>
+        </p:txBody>
+      </p:sp>
+      <p:sp>
+        <p:nvSpPr>
+          <p:cNvPr id="15" name="Text 11"/>
+          <p:cNvSpPr/>
+          <p:nvPr/>
+        </p:nvSpPr>
+        <p:spPr>
+          <a:xfrm>
+            <a:off x="11521440" y="6446520"/>
+            <a:ext cx="457200" cy="274320"/>
+          </a:xfrm>
+          <a:prstGeom prst="rect">
+            <a:avLst/>
+          </a:prstGeom>
+          <a:noFill/>
+          <a:ln/>
+        </p:spPr>
+        <p:txBody>
+          <a:bodyPr wrap="square" rtlCol="0" anchor="ctr"/>
+          <a:lstStyle/>
+          <a:p>
+            <a:pPr algn="r" indent="0" marL="0">
+              <a:buNone/>
+            </a:pPr>
+            <a:r>
+              <a:rPr lang="en-US" sz="900" dirty="0">
+                <a:solidFill>
+                  <a:srgbClr val="8C96A3"/>
+                </a:solidFill>
+              </a:rPr>
+              <a:t>11</a:t>
+            </a:r>
+            <a:endParaRPr lang="en-US" sz="900" dirty="0"/>
+          </a:p>
+        </p:txBody>
+      </p:sp>
+    </p:spTree>
+  </p:cSld>
+  <p:clrMapOvr>
+    <a:masterClrMapping/>
+  </p:clrMapOvr>
+</p:sld>
+</file>
+
+<file path=ppt/slides/slide12.xml><?xml version="1.0" encoding="utf-8"?>
+<p:sld xmlns:a="http://schemas.openxmlformats.org/drawingml/2006/main" xmlns:r="http://schemas.openxmlformats.org/officeDocument/2006/relationships" xmlns:p="http://schemas.openxmlformats.org/presentationml/2006/main">
+  <p:cSld name="Slide 12">
     <p:bg>
       <p:bgPr>
         <a:solidFill>
@@ -3081,7 +3365,7 @@
                   <a:srgbClr val="8C96A3"/>
                 </a:solidFill>
               </a:rPr>
-              <a:t>11</a:t>
+              <a:t>12</a:t>
             </a:r>
             <a:endParaRPr lang="en-US" sz="900" dirty="0"/>
           </a:p>
@@ -3095,9 +3379,9 @@
 </p:sld>
 </file>
 
-<file path=ppt/slides/slide12.xml><?xml version="1.0" encoding="utf-8"?>
+<file path=ppt/slides/slide13.xml><?xml version="1.0" encoding="utf-8"?>
 <p:sld xmlns:a="http://schemas.openxmlformats.org/drawingml/2006/main" xmlns:r="http://schemas.openxmlformats.org/officeDocument/2006/relationships" xmlns:p="http://schemas.openxmlformats.org/presentationml/2006/main">
-  <p:cSld name="Slide 12">
+  <p:cSld name="Slide 13">
     <p:spTree>
       <p:nvGrpSpPr>
         <p:cNvPr id="1" name=""/>
@@ -3388,7 +3672,7 @@
                   <a:srgbClr val="8C96A3"/>
                 </a:solidFill>
               </a:rPr>
-              <a:t>12</a:t>
+              <a:t>13</a:t>
             </a:r>
             <a:endParaRPr lang="en-US" sz="900" dirty="0"/>
           </a:p>

</xml_diff>